<commit_message>
adds more CFS examples
</commit_message>
<xml_diff>
--- a/Python/CONTROL FLOW STRUCTURES (lessons #7 - )/PowerPoints & PDFs/Lesson +#7 - Making decisions (CFGs).pptx
+++ b/Python/CONTROL FLOW STRUCTURES (lessons #7 - )/PowerPoints & PDFs/Lesson +#7 - Making decisions (CFGs).pptx
@@ -273,7 +273,7 @@
           <a:p>
             <a:fld id="{E87FDB18-98E6-4A2B-A3F6-0B25054C7CB3}" type="datetimeFigureOut">
               <a:rPr lang="en-US" smtClean="0"/>
-              <a:t>4/21/2026</a:t>
+              <a:t>4/22/2026</a:t>
             </a:fld>
             <a:endParaRPr lang="en-US"/>
           </a:p>
@@ -473,7 +473,7 @@
           <a:p>
             <a:fld id="{E87FDB18-98E6-4A2B-A3F6-0B25054C7CB3}" type="datetimeFigureOut">
               <a:rPr lang="en-US" smtClean="0"/>
-              <a:t>4/21/2026</a:t>
+              <a:t>4/22/2026</a:t>
             </a:fld>
             <a:endParaRPr lang="en-US"/>
           </a:p>
@@ -683,7 +683,7 @@
           <a:p>
             <a:fld id="{E87FDB18-98E6-4A2B-A3F6-0B25054C7CB3}" type="datetimeFigureOut">
               <a:rPr lang="en-US" smtClean="0"/>
-              <a:t>4/21/2026</a:t>
+              <a:t>4/22/2026</a:t>
             </a:fld>
             <a:endParaRPr lang="en-US"/>
           </a:p>
@@ -883,7 +883,7 @@
           <a:p>
             <a:fld id="{E87FDB18-98E6-4A2B-A3F6-0B25054C7CB3}" type="datetimeFigureOut">
               <a:rPr lang="en-US" smtClean="0"/>
-              <a:t>4/21/2026</a:t>
+              <a:t>4/22/2026</a:t>
             </a:fld>
             <a:endParaRPr lang="en-US"/>
           </a:p>
@@ -1159,7 +1159,7 @@
           <a:p>
             <a:fld id="{E87FDB18-98E6-4A2B-A3F6-0B25054C7CB3}" type="datetimeFigureOut">
               <a:rPr lang="en-US" smtClean="0"/>
-              <a:t>4/21/2026</a:t>
+              <a:t>4/22/2026</a:t>
             </a:fld>
             <a:endParaRPr lang="en-US"/>
           </a:p>
@@ -1427,7 +1427,7 @@
           <a:p>
             <a:fld id="{E87FDB18-98E6-4A2B-A3F6-0B25054C7CB3}" type="datetimeFigureOut">
               <a:rPr lang="en-US" smtClean="0"/>
-              <a:t>4/21/2026</a:t>
+              <a:t>4/22/2026</a:t>
             </a:fld>
             <a:endParaRPr lang="en-US"/>
           </a:p>
@@ -1842,7 +1842,7 @@
           <a:p>
             <a:fld id="{E87FDB18-98E6-4A2B-A3F6-0B25054C7CB3}" type="datetimeFigureOut">
               <a:rPr lang="en-US" smtClean="0"/>
-              <a:t>4/21/2026</a:t>
+              <a:t>4/22/2026</a:t>
             </a:fld>
             <a:endParaRPr lang="en-US"/>
           </a:p>
@@ -1984,7 +1984,7 @@
           <a:p>
             <a:fld id="{E87FDB18-98E6-4A2B-A3F6-0B25054C7CB3}" type="datetimeFigureOut">
               <a:rPr lang="en-US" smtClean="0"/>
-              <a:t>4/21/2026</a:t>
+              <a:t>4/22/2026</a:t>
             </a:fld>
             <a:endParaRPr lang="en-US"/>
           </a:p>
@@ -2097,7 +2097,7 @@
           <a:p>
             <a:fld id="{E87FDB18-98E6-4A2B-A3F6-0B25054C7CB3}" type="datetimeFigureOut">
               <a:rPr lang="en-US" smtClean="0"/>
-              <a:t>4/21/2026</a:t>
+              <a:t>4/22/2026</a:t>
             </a:fld>
             <a:endParaRPr lang="en-US"/>
           </a:p>
@@ -2410,7 +2410,7 @@
           <a:p>
             <a:fld id="{E87FDB18-98E6-4A2B-A3F6-0B25054C7CB3}" type="datetimeFigureOut">
               <a:rPr lang="en-US" smtClean="0"/>
-              <a:t>4/21/2026</a:t>
+              <a:t>4/22/2026</a:t>
             </a:fld>
             <a:endParaRPr lang="en-US"/>
           </a:p>
@@ -2699,7 +2699,7 @@
           <a:p>
             <a:fld id="{E87FDB18-98E6-4A2B-A3F6-0B25054C7CB3}" type="datetimeFigureOut">
               <a:rPr lang="en-US" smtClean="0"/>
-              <a:t>4/21/2026</a:t>
+              <a:t>4/22/2026</a:t>
             </a:fld>
             <a:endParaRPr lang="en-US"/>
           </a:p>
@@ -2942,7 +2942,7 @@
           <a:p>
             <a:fld id="{E87FDB18-98E6-4A2B-A3F6-0B25054C7CB3}" type="datetimeFigureOut">
               <a:rPr lang="en-US" smtClean="0"/>
-              <a:t>4/21/2026</a:t>
+              <a:t>4/22/2026</a:t>
             </a:fld>
             <a:endParaRPr lang="en-US"/>
           </a:p>
@@ -5554,7 +5554,7 @@
         </p:nvSpPr>
         <p:spPr>
           <a:xfrm>
-            <a:off x="7793088" y="5551389"/>
+            <a:off x="7715814" y="5551389"/>
             <a:ext cx="2743200" cy="369332"/>
           </a:xfrm>
           <a:prstGeom prst="rect">
@@ -5575,7 +5575,7 @@
             </a:r>
             <a:r>
               <a:rPr lang="en-US" dirty="0" err="1"/>
-              <a:t>full_names</a:t>
+              <a:t>numbers_times_two</a:t>
             </a:r>
             <a:r>
               <a:rPr lang="en-US" dirty="0"/>
@@ -6419,6 +6419,36 @@
           </p:txBody>
         </p:sp>
       </p:grpSp>
+      <p:pic>
+        <p:nvPicPr>
+          <p:cNvPr id="22" name="Imagen 21">
+            <a:extLst>
+              <a:ext uri="{FF2B5EF4-FFF2-40B4-BE49-F238E27FC236}">
+                <a16:creationId xmlns:a16="http://schemas.microsoft.com/office/drawing/2014/main" id="{4B0357F6-5935-71A4-D2C2-2F474EDCC5D9}"/>
+              </a:ext>
+            </a:extLst>
+          </p:cNvPr>
+          <p:cNvPicPr>
+            <a:picLocks noChangeAspect="1"/>
+          </p:cNvPicPr>
+          <p:nvPr/>
+        </p:nvPicPr>
+        <p:blipFill>
+          <a:blip r:embed="rId3"/>
+          <a:stretch>
+            <a:fillRect/>
+          </a:stretch>
+        </p:blipFill>
+        <p:spPr>
+          <a:xfrm>
+            <a:off x="-31787" y="4784346"/>
+            <a:ext cx="7312364" cy="2073654"/>
+          </a:xfrm>
+          <a:prstGeom prst="rect">
+            <a:avLst/>
+          </a:prstGeom>
+        </p:spPr>
+      </p:pic>
     </p:spTree>
     <p:extLst>
       <p:ext uri="{BB962C8B-B14F-4D97-AF65-F5344CB8AC3E}">

</xml_diff>